<commit_message>
Welcome beginners without an opening assessment
</commit_message>
<xml_diff>
--- a/03_Presentations/W01_signal.pptx
+++ b/03_Presentations/W01_signal.pptx
@@ -2,18 +2,18 @@
 <file path=ppt/presentation.xml><?xml version="1.0" encoding="utf-8"?>
 <p:presentation xmlns:p="http://schemas.openxmlformats.org/presentationml/2006/main">
   <p:sldMasterIdLst>
-    <p:sldMasterId xmlns:r="http://schemas.openxmlformats.org/officeDocument/2006/relationships" id="2147483648" r:id="Rafd3078dfc7f45c5"/>
+    <p:sldMasterId xmlns:r="http://schemas.openxmlformats.org/officeDocument/2006/relationships" id="2147483648" r:id="Rcd8c773133e94c02"/>
   </p:sldMasterIdLst>
   <p:notesMasterIdLst>
-    <p:notesMasterId xmlns:r="http://schemas.openxmlformats.org/officeDocument/2006/relationships" r:id="R730d262d907b4d65"/>
+    <p:notesMasterId xmlns:r="http://schemas.openxmlformats.org/officeDocument/2006/relationships" r:id="Rcd705ce72c3a467a"/>
   </p:notesMasterIdLst>
   <p:sldIdLst>
-    <p:sldId xmlns:r="http://schemas.openxmlformats.org/officeDocument/2006/relationships" id="256" r:id="R78f7a9068a3f468f"/>
-    <p:sldId xmlns:r="http://schemas.openxmlformats.org/officeDocument/2006/relationships" id="257" r:id="Rac230f5f01bf4004"/>
-    <p:sldId xmlns:r="http://schemas.openxmlformats.org/officeDocument/2006/relationships" id="258" r:id="R2de5b0e8985b459a"/>
-    <p:sldId xmlns:r="http://schemas.openxmlformats.org/officeDocument/2006/relationships" id="259" r:id="R70b1403d2cb74e0c"/>
-    <p:sldId xmlns:r="http://schemas.openxmlformats.org/officeDocument/2006/relationships" id="260" r:id="Rda041a035a324139"/>
-    <p:sldId xmlns:r="http://schemas.openxmlformats.org/officeDocument/2006/relationships" id="261" r:id="R7d19f807b95e4ec6"/>
+    <p:sldId xmlns:r="http://schemas.openxmlformats.org/officeDocument/2006/relationships" id="256" r:id="R9fa4546387984359"/>
+    <p:sldId xmlns:r="http://schemas.openxmlformats.org/officeDocument/2006/relationships" id="257" r:id="R9205864de1744b97"/>
+    <p:sldId xmlns:r="http://schemas.openxmlformats.org/officeDocument/2006/relationships" id="258" r:id="Re8fb9d0139bd41a3"/>
+    <p:sldId xmlns:r="http://schemas.openxmlformats.org/officeDocument/2006/relationships" id="259" r:id="Rd7a9ca7333a34683"/>
+    <p:sldId xmlns:r="http://schemas.openxmlformats.org/officeDocument/2006/relationships" id="260" r:id="R20c5dedccd2b4868"/>
+    <p:sldId xmlns:r="http://schemas.openxmlformats.org/officeDocument/2006/relationships" id="261" r:id="R029a2a1c5757471e"/>
   </p:sldIdLst>
   <p:sldSz cx="12192000" cy="6858000"/>
   <p:notesSz cx="6858000" cy="9144000"/>
@@ -447,7 +447,7 @@
           <a:lstStyle xmlns:a="http://schemas.openxmlformats.org/drawingml/2006/main"/>
           <a:p xmlns:a="http://schemas.openxmlformats.org/drawingml/2006/main">
             <a:r>
-              <a:t>PREPARATION</a:t>
+              <a:t>Slide 1 Meet your robot</a:t>
             </a:r>
           </a:p>
           <a:p xmlns:a="http://schemas.openxmlformats.org/drawingml/2006/main">
@@ -457,7 +457,7 @@
           </a:p>
           <a:p xmlns:a="http://schemas.openxmlformats.org/drawingml/2006/main">
             <a:r>
-              <a:t>Week 1 Meet your robot</a:t>
+              <a:t>Timing 0–5 minutes</a:t>
             </a:r>
           </a:p>
           <a:p xmlns:a="http://schemas.openxmlformats.org/drawingml/2006/main">
@@ -467,7 +467,7 @@
           </a:p>
           <a:p xmlns:a="http://schemas.openxmlformats.org/drawingml/2006/main">
             <a:r>
-              <a:t>Speaker notes for the six-slide class presentation. Use the slides as brief prompts and leave time for children to build, operate and explain. This is a robotics session with a small prepared Python recipe.</a:t>
+              <a:t>Say Welcome to robotics at the YMCA. You will make a robot signal and move, and build its own mascot. Each of you gets a turn.</a:t>
             </a:r>
           </a:p>
           <a:p xmlns:a="http://schemas.openxmlformats.org/drawingml/2006/main">
@@ -477,7 +477,7 @@
           </a:p>
           <a:p xmlns:a="http://schemas.openxmlformats.org/drawingml/2006/main">
             <a:r>
-              <a:t>Class setup</a:t>
+              <a:t>Do Introduce mentors and seat T1/T2 at Pod A, T3/T4 at Pod B. Invite children to share their names. Prior experience was already asked about; use no opening worksheet, quiz or ability rating. Say: Today you will make a robot move and build something for it. Everyone gets a turn, and we will help you with each step.</a:t>
             </a:r>
           </a:p>
           <a:p xmlns:a="http://schemas.openxmlformats.org/drawingml/2006/main">
@@ -487,107 +487,7 @@
           </a:p>
           <a:p xmlns:a="http://schemas.openxmlformats.org/drawingml/2006/main">
             <a:r>
-              <a:t>12 children in grades 5–6 form four teams of three: T1/T2 share Kit A and T3/T4 share Kit B. Four student instructors cover two robot stations and two build tables; a fifth or sixth can float. The adult lead oversees the room and YMCA procedures. Bring four available laptops: two remain connected to robots and two show build references. Printed build cards make the build activity work with two laptops too.</a:t>
-            </a:r>
-          </a:p>
-          <a:p xmlns:a="http://schemas.openxmlformats.org/drawingml/2006/main">
-            <a:r>
-              <a:t/>
-            </a:r>
-          </a:p>
-          <a:p xmlns:a="http://schemas.openxmlformats.org/drawingml/2006/main">
-            <a:r>
-              <a:t>Learning goal Each child changes a short robot message, predicts a short action sequence, and explains that a robot follows the order of its instructions.</a:t>
-            </a:r>
-          </a:p>
-          <a:p xmlns:a="http://schemas.openxmlformats.org/drawingml/2006/main">
-            <a:r>
-              <a:t/>
-            </a:r>
-          </a:p>
-          <a:p xmlns:a="http://schemas.openxmlformats.org/drawingml/2006/main">
-            <a:r>
-              <a:t>Minimum success The team displays its chosen one-letter signal, runs one short forward movement, and all three teammates identify which instruction happened first.</a:t>
-            </a:r>
-          </a:p>
-          <a:p xmlns:a="http://schemas.openxmlformats.org/drawingml/2006/main">
-            <a:r>
-              <a:t/>
-            </a:r>
-          </a:p>
-          <a:p xmlns:a="http://schemas.openxmlformats.org/drawingml/2006/main">
-            <a:r>
-              <a:t>Prepare Keep wheels raised for the first signal run. Open W01_signal.py in a SPIKE Prime Python project. Confirm the A/B motor mapping with the mentor smoke test. Hand out the baseline before explaining code. Prepare two mentor examples and four labeled team build packs. Rehearse attachment clearance, a hand test and a quick swap. Show the hub color guide.</a:t>
-            </a:r>
-          </a:p>
-          <a:p xmlns:a="http://schemas.openxmlformats.org/drawingml/2006/main">
-            <a:r>
-              <a:t/>
-            </a:r>
-          </a:p>
-          <a:p xmlns:a="http://schemas.openxmlformats.org/drawingml/2006/main">
-            <a:r>
-              <a:t>Materials and files Print and pack from the matching checklist in 01_Instructor/Class_Preparation. Use the team sheet and build card. Keep the original two bases assembled, A left/B right, auxiliary motor unplugged; add C/D only as the lessons require. Hardware rehearsal remains required.</a:t>
-            </a:r>
-          </a:p>
-          <a:p xmlns:a="http://schemas.openxmlformats.org/drawingml/2006/main">
-            <a:r>
-              <a:t/>
-            </a:r>
-          </a:p>
-          <a:p xmlns:a="http://schemas.openxmlformats.org/drawingml/2006/main">
-            <a:r>
-              <a:t>Week 1 setup Build both official Practice Driving Bases before class. R3PTAR is separate and does not replace a teaching kit. The LEGO build PDF is in 06_References. Check the actual forward direction, stop controls, connection and save/export workflow on both teaching devices.</a:t>
-            </a:r>
-          </a:p>
-          <a:p xmlns:a="http://schemas.openxmlformats.org/drawingml/2006/main">
-            <a:r>
-              <a:t/>
-            </a:r>
-          </a:p>
-          <a:p xmlns:a="http://schemas.openxmlformats.org/drawingml/2006/main">
-            <a:r>
-              <a:t>Slide 1 Meet your robot</a:t>
-            </a:r>
-          </a:p>
-          <a:p xmlns:a="http://schemas.openxmlformats.org/drawingml/2006/main">
-            <a:r>
-              <a:t/>
-            </a:r>
-          </a:p>
-          <a:p xmlns:a="http://schemas.openxmlformats.org/drawingml/2006/main">
-            <a:r>
-              <a:t>Timing 0–5 minutes</a:t>
-            </a:r>
-          </a:p>
-          <a:p xmlns:a="http://schemas.openxmlformats.org/drawingml/2006/main">
-            <a:r>
-              <a:t/>
-            </a:r>
-          </a:p>
-          <a:p xmlns:a="http://schemas.openxmlformats.org/drawingml/2006/main">
-            <a:r>
-              <a:t>Say Welcome to robotics at the YMCA. You will make a robot signal and move, and build its own mascot. Each of you gets a turn.</a:t>
-            </a:r>
-          </a:p>
-          <a:p xmlns:a="http://schemas.openxmlformats.org/drawingml/2006/main">
-            <a:r>
-              <a:t/>
-            </a:r>
-          </a:p>
-          <a:p xmlns:a="http://schemas.openxmlformats.org/drawingml/2006/main">
-            <a:r>
-              <a:t>Do Introduce mentors and seat T1/T2 at Pod A, T3/T4 at Pod B. Keep robots stopped. Give the individual baseline before displaying or teaching the code. Read aloud or accept pointing without coaching answers. Collect by student ID.</a:t>
-            </a:r>
-          </a:p>
-          <a:p xmlns:a="http://schemas.openxmlformats.org/drawingml/2006/main">
-            <a:r>
-              <a:t/>
-            </a:r>
-          </a:p>
-          <a:p xmlns:a="http://schemas.openxmlformats.org/drawingml/2006/main">
-            <a:r>
-              <a:t>Say One driver starts after the navigator calls clear. Hands stay away while it moves. Anyone may call stop. Demonstrate the actual stop control after the baseline.</a:t>
+              <a:t>Say One driver starts after the navigator calls clear. Hands stay away while it moves. Anyone may call stop. Demonstrate the actual stop control before any robot moves.</a:t>
             </a:r>
           </a:p>
         </p:txBody>
@@ -718,16 +618,6 @@
           <a:p xmlns:a="http://schemas.openxmlformats.org/drawingml/2006/main">
             <a:r>
               <a:t>Hub check Read the light on the correct button: steady green center means powered on with a compatible OS and at least 20% battery; flashing orange center means charge; flashing red center means stop, power off and cool for 15 minutes. White center needs a compatible OS; flashing purple center means updating. Blue is the connection button: flashing means waiting for Bluetooth, steady means connected. A display letter is a program output, not a battery or connection status. See the full SPIKE Hub Color Guide.</a:t>
-            </a:r>
-          </a:p>
-          <a:p xmlns:a="http://schemas.openxmlformats.org/drawingml/2006/main">
-            <a:r>
-              <a:t/>
-            </a:r>
-          </a:p>
-          <a:p xmlns:a="http://schemas.openxmlformats.org/drawingml/2006/main">
-            <a:r>
-              <a:t>Image credit: LEGO Education Practice Driving Base. https://education.lego.com/en-us/lessons/prime-competition-ready/training-camp-1-driving-around/</a:t>
             </a:r>
           </a:p>
         </p:txBody>
@@ -1355,7 +1245,7 @@
   </p:cSld>
   <p:clrMap bg1="lt1" tx1="dk1" bg2="lt2" tx2="dk2" accent1="accent1" accent2="accent2" accent3="accent3" accent4="accent4" accent5="accent5" accent6="accent6" hlink="hlink" folHlink="folHlink"/>
   <p:sldLayoutIdLst>
-    <p:sldLayoutId xmlns:r="http://schemas.openxmlformats.org/officeDocument/2006/relationships" id="2147483649" r:id="Re372db83e4854284"/>
+    <p:sldLayoutId xmlns:r="http://schemas.openxmlformats.org/officeDocument/2006/relationships" id="2147483649" r:id="Rdf1a060d984646d9"/>
   </p:sldLayoutIdLst>
   <p:txStyles>
     <p:titleStyle>
@@ -2341,7 +2231,7 @@
           <p:cNvPr id="10" name="">
             <a:extLst xmlns:a="http://schemas.openxmlformats.org/drawingml/2006/main">
               <a:ext uri="{FF2B5EF4-FFF2-40B4-BE49-F238E27FC236}">
-                <a16:creationId xmlns:a16="http://schemas.microsoft.com/office/drawing/2014/main" id="{941F6B53-8658-4326-8583-0DC164398BDC}"/>
+                <a16:creationId xmlns:a16="http://schemas.microsoft.com/office/drawing/2014/main" id="{3D6F28FD-9D79-4F46-8AC5-1FB23EC91ABB}"/>
               </a:ext>
             </a:extLst>
           </p:cNvPr>
@@ -2351,7 +2241,7 @@
           <p:nvPr/>
         </p:nvPicPr>
         <p:blipFill>
-          <a:blip xmlns:r="http://schemas.openxmlformats.org/officeDocument/2006/relationships" xmlns:a="http://schemas.openxmlformats.org/drawingml/2006/main" r:embed="Rb5177ca7f4e04aa3"/>
+          <a:blip xmlns:r="http://schemas.openxmlformats.org/officeDocument/2006/relationships" xmlns:a="http://schemas.openxmlformats.org/drawingml/2006/main" r:embed="R8f32f3f92eea47de"/>
           <a:stretch xmlns:a="http://schemas.openxmlformats.org/drawingml/2006/main"/>
         </p:blipFill>
         <p:spPr>

</xml_diff>

<commit_message>
Plan remaining sessions and add optional timed delivery challenge
</commit_message>
<xml_diff>
--- a/03_Presentations/W01_signal.pptx
+++ b/03_Presentations/W01_signal.pptx
@@ -2,18 +2,18 @@
 <file path=ppt/presentation.xml><?xml version="1.0" encoding="utf-8"?>
 <p:presentation xmlns:p="http://schemas.openxmlformats.org/presentationml/2006/main">
   <p:sldMasterIdLst>
-    <p:sldMasterId xmlns:r="http://schemas.openxmlformats.org/officeDocument/2006/relationships" id="2147483648" r:id="Rcd8c773133e94c02"/>
+    <p:sldMasterId xmlns:r="http://schemas.openxmlformats.org/officeDocument/2006/relationships" id="2147483648" r:id="Rc8f1b6d8f5434036"/>
   </p:sldMasterIdLst>
   <p:notesMasterIdLst>
-    <p:notesMasterId xmlns:r="http://schemas.openxmlformats.org/officeDocument/2006/relationships" r:id="Rcd705ce72c3a467a"/>
+    <p:notesMasterId xmlns:r="http://schemas.openxmlformats.org/officeDocument/2006/relationships" r:id="Rbeb8ccf861b64a6a"/>
   </p:notesMasterIdLst>
   <p:sldIdLst>
-    <p:sldId xmlns:r="http://schemas.openxmlformats.org/officeDocument/2006/relationships" id="256" r:id="R9fa4546387984359"/>
-    <p:sldId xmlns:r="http://schemas.openxmlformats.org/officeDocument/2006/relationships" id="257" r:id="R9205864de1744b97"/>
-    <p:sldId xmlns:r="http://schemas.openxmlformats.org/officeDocument/2006/relationships" id="258" r:id="Re8fb9d0139bd41a3"/>
-    <p:sldId xmlns:r="http://schemas.openxmlformats.org/officeDocument/2006/relationships" id="259" r:id="Rd7a9ca7333a34683"/>
-    <p:sldId xmlns:r="http://schemas.openxmlformats.org/officeDocument/2006/relationships" id="260" r:id="R20c5dedccd2b4868"/>
-    <p:sldId xmlns:r="http://schemas.openxmlformats.org/officeDocument/2006/relationships" id="261" r:id="R029a2a1c5757471e"/>
+    <p:sldId xmlns:r="http://schemas.openxmlformats.org/officeDocument/2006/relationships" id="256" r:id="Rc2b7166d8b6a4621"/>
+    <p:sldId xmlns:r="http://schemas.openxmlformats.org/officeDocument/2006/relationships" id="257" r:id="Rdf1417bb70d34eaa"/>
+    <p:sldId xmlns:r="http://schemas.openxmlformats.org/officeDocument/2006/relationships" id="258" r:id="Rf5e3f2e34fe944b7"/>
+    <p:sldId xmlns:r="http://schemas.openxmlformats.org/officeDocument/2006/relationships" id="259" r:id="R7db4abeb57194018"/>
+    <p:sldId xmlns:r="http://schemas.openxmlformats.org/officeDocument/2006/relationships" id="260" r:id="Rb306222a65844bf9"/>
+    <p:sldId xmlns:r="http://schemas.openxmlformats.org/officeDocument/2006/relationships" id="261" r:id="R9c1f232e9d1541e0"/>
   </p:sldIdLst>
   <p:sldSz cx="12192000" cy="6858000"/>
   <p:notesSz cx="6858000" cy="9144000"/>
@@ -447,6 +447,106 @@
           <a:lstStyle xmlns:a="http://schemas.openxmlformats.org/drawingml/2006/main"/>
           <a:p xmlns:a="http://schemas.openxmlformats.org/drawingml/2006/main">
             <a:r>
+              <a:t>PREPARATION</a:t>
+            </a:r>
+          </a:p>
+          <a:p xmlns:a="http://schemas.openxmlformats.org/drawingml/2006/main">
+            <a:r>
+              <a:t/>
+            </a:r>
+          </a:p>
+          <a:p xmlns:a="http://schemas.openxmlformats.org/drawingml/2006/main">
+            <a:r>
+              <a:t>Week 1 Meet your robot</a:t>
+            </a:r>
+          </a:p>
+          <a:p xmlns:a="http://schemas.openxmlformats.org/drawingml/2006/main">
+            <a:r>
+              <a:t/>
+            </a:r>
+          </a:p>
+          <a:p xmlns:a="http://schemas.openxmlformats.org/drawingml/2006/main">
+            <a:r>
+              <a:t>Speaker notes for the six-slide class presentation. Use the slides as brief prompts and leave time for children to build, operate and explain. This is a robotics session with a small prepared Python recipe.</a:t>
+            </a:r>
+          </a:p>
+          <a:p xmlns:a="http://schemas.openxmlformats.org/drawingml/2006/main">
+            <a:r>
+              <a:t/>
+            </a:r>
+          </a:p>
+          <a:p xmlns:a="http://schemas.openxmlformats.org/drawingml/2006/main">
+            <a:r>
+              <a:t>Class setup</a:t>
+            </a:r>
+          </a:p>
+          <a:p xmlns:a="http://schemas.openxmlformats.org/drawingml/2006/main">
+            <a:r>
+              <a:t/>
+            </a:r>
+          </a:p>
+          <a:p xmlns:a="http://schemas.openxmlformats.org/drawingml/2006/main">
+            <a:r>
+              <a:t>12 children in grades 5–6 form four teams of three: T1/T2 share Kit A and T3/T4 share Kit B. Four student instructors cover two robot stations and two build tables; a fifth or sixth can float. The adult lead oversees the room and YMCA procedures. Bring four available laptops: two remain connected to robots and two show build references. Printed build cards make the build activity work with two laptops too.</a:t>
+            </a:r>
+          </a:p>
+          <a:p xmlns:a="http://schemas.openxmlformats.org/drawingml/2006/main">
+            <a:r>
+              <a:t/>
+            </a:r>
+          </a:p>
+          <a:p xmlns:a="http://schemas.openxmlformats.org/drawingml/2006/main">
+            <a:r>
+              <a:t>Learning goal Each child changes a short robot message, predicts a short action sequence, and explains that a robot follows the order of its instructions.</a:t>
+            </a:r>
+          </a:p>
+          <a:p xmlns:a="http://schemas.openxmlformats.org/drawingml/2006/main">
+            <a:r>
+              <a:t/>
+            </a:r>
+          </a:p>
+          <a:p xmlns:a="http://schemas.openxmlformats.org/drawingml/2006/main">
+            <a:r>
+              <a:t>Minimum success The team displays its chosen one-letter signal, runs one short forward movement, and all three teammates identify which instruction happened first.</a:t>
+            </a:r>
+          </a:p>
+          <a:p xmlns:a="http://schemas.openxmlformats.org/drawingml/2006/main">
+            <a:r>
+              <a:t/>
+            </a:r>
+          </a:p>
+          <a:p xmlns:a="http://schemas.openxmlformats.org/drawingml/2006/main">
+            <a:r>
+              <a:t>Prepare Keep wheels raised for the first signal run. Open W01_signal.py in a SPIKE Prime Python project. Confirm the A/B motor mapping with the mentor smoke test. Start with names and a welcoming introduction; use no opening quiz or ability rating. Prepare two mentor examples and four labeled team build packs. Rehearse attachment clearance, a hand test and a quick swap. Show the hub color guide.</a:t>
+            </a:r>
+          </a:p>
+          <a:p xmlns:a="http://schemas.openxmlformats.org/drawingml/2006/main">
+            <a:r>
+              <a:t/>
+            </a:r>
+          </a:p>
+          <a:p xmlns:a="http://schemas.openxmlformats.org/drawingml/2006/main">
+            <a:r>
+              <a:t>Materials and files Print and pack from the matching checklist in 01_Instructor/Class_Preparation. Use the team sheet and build card. Keep the original two bases assembled, A left/B right, auxiliary motor unplugged; add C/D only as the lessons require. Hardware rehearsal remains required.</a:t>
+            </a:r>
+          </a:p>
+          <a:p xmlns:a="http://schemas.openxmlformats.org/drawingml/2006/main">
+            <a:r>
+              <a:t/>
+            </a:r>
+          </a:p>
+          <a:p xmlns:a="http://schemas.openxmlformats.org/drawingml/2006/main">
+            <a:r>
+              <a:t>Week 1 setup Build both official Practice Driving Bases before class. R3PTAR is separate and does not replace a teaching kit. The LEGO build PDF is in 06_References. Check the actual forward direction, stop controls, connection and save/export workflow on both teaching devices.</a:t>
+            </a:r>
+          </a:p>
+          <a:p xmlns:a="http://schemas.openxmlformats.org/drawingml/2006/main">
+            <a:r>
+              <a:t/>
+            </a:r>
+          </a:p>
+          <a:p xmlns:a="http://schemas.openxmlformats.org/drawingml/2006/main">
+            <a:r>
               <a:t>Slide 1 Meet your robot</a:t>
             </a:r>
           </a:p>
@@ -1245,7 +1345,7 @@
   </p:cSld>
   <p:clrMap bg1="lt1" tx1="dk1" bg2="lt2" tx2="dk2" accent1="accent1" accent2="accent2" accent3="accent3" accent4="accent4" accent5="accent5" accent6="accent6" hlink="hlink" folHlink="folHlink"/>
   <p:sldLayoutIdLst>
-    <p:sldLayoutId xmlns:r="http://schemas.openxmlformats.org/officeDocument/2006/relationships" id="2147483649" r:id="Rdf1a060d984646d9"/>
+    <p:sldLayoutId xmlns:r="http://schemas.openxmlformats.org/officeDocument/2006/relationships" id="2147483649" r:id="R4efb2f8d2ecd42b7"/>
   </p:sldLayoutIdLst>
   <p:txStyles>
     <p:titleStyle>
@@ -2231,7 +2331,7 @@
           <p:cNvPr id="10" name="">
             <a:extLst xmlns:a="http://schemas.openxmlformats.org/drawingml/2006/main">
               <a:ext uri="{FF2B5EF4-FFF2-40B4-BE49-F238E27FC236}">
-                <a16:creationId xmlns:a16="http://schemas.microsoft.com/office/drawing/2014/main" id="{3D6F28FD-9D79-4F46-8AC5-1FB23EC91ABB}"/>
+                <a16:creationId xmlns:a16="http://schemas.microsoft.com/office/drawing/2014/main" id="{8E72D690-CF28-446D-8E48-A045AD8CE90B}"/>
               </a:ext>
             </a:extLst>
           </p:cNvPr>
@@ -2241,7 +2341,7 @@
           <p:nvPr/>
         </p:nvPicPr>
         <p:blipFill>
-          <a:blip xmlns:r="http://schemas.openxmlformats.org/officeDocument/2006/relationships" xmlns:a="http://schemas.openxmlformats.org/drawingml/2006/main" r:embed="R8f32f3f92eea47de"/>
+          <a:blip xmlns:r="http://schemas.openxmlformats.org/officeDocument/2006/relationships" xmlns:a="http://schemas.openxmlformats.org/drawingml/2006/main" r:embed="R9e6229a38d454999"/>
           <a:stretch xmlns:a="http://schemas.openxmlformats.org/drawingml/2006/main"/>
         </p:blipFill>
         <p:spPr>

</xml_diff>